<commit_message>
Images for PPTX (p:pic) and DOCX (inline w:drawing)
Uses dv-image (M0) + the existing Command::Image. PPTX: p:pic blipFill a:blip
r:embed -> slide rels -> ppt/media, drawn at the shape's a:off/a:ext rect. DOCX:
run w:drawing wp:extent + a:blip r:embed -> document rels -> word/media, rendered
as an inline image block scaled to fit content width. Shared rels/path-resolve
helpers; decode -> Command::Image -> tiny-skia bilinear blit.

Verified in-browser: PPTX slide shows the embedded PNG beside text; DOCX page
shows the inline PNG between heading and lists. Core wasm 1.5MB -> 1.7MB (decoders).

Co-Authored-By: Claude Opus 4.8 (1M context) <noreply@anthropic.com>
</commit_message>
<xml_diff>
--- a/examples/assets/sample.pptx
+++ b/examples/assets/sample.pptx
@@ -94,7 +94,7 @@
         <p:spPr>
           <a:xfrm>
             <a:off x="914400" y="2926080"/>
-            <a:ext cx="7315200" cy="2286000"/>
+            <a:ext cx="3840480" cy="2286000"/>
           </a:xfrm>
           <a:prstGeom prst="rect">
             <a:avLst/>
@@ -112,7 +112,7 @@
                   <a:srgbClr val="374151"/>
                 </a:solidFill>
               </a:rPr>
-              <a:t>• 自寫 Rust 解析 DrawingML 形狀座標(EMU)</a:t>
+              <a:t>• 自寫 Rust 解析 DrawingML</a:t>
             </a:r>
           </a:p>
           <a:p>
@@ -123,7 +123,7 @@
                   <a:srgbClr val="374151"/>
                 </a:solidFill>
               </a:rPr>
-              <a:t>• 定位文字框、run 格式(字級/粗體/顏色)、段落對齊</a:t>
+              <a:t>• 定位文字框、run 格式</a:t>
             </a:r>
           </a:p>
           <a:p>
@@ -134,11 +134,33 @@
                   <a:srgbClr val="C0504D"/>
                 </a:solidFill>
               </a:rPr>
-              <a:t>• Positioned text boxes rendered via the shared geba</a:t>
-            </a:r>
-          </a:p>
-        </p:txBody>
-      </p:sp>
+              <a:t>• 內嵌 PNG/JPEG 圖片 →</a:t>
+            </a:r>
+          </a:p>
+        </p:txBody>
+      </p:sp>
+      <p:pic>
+        <p:nvPicPr>
+          <p:cNvPr id="9" name="pic9"/>
+          <p:cNvPicPr/>
+          <p:nvPr/>
+        </p:nvPicPr>
+        <p:blipFill>
+          <a:blip r:embed="rId1"/>
+          <a:stretch>
+            <a:fillRect/>
+          </a:stretch>
+        </p:blipFill>
+        <p:spPr>
+          <a:xfrm>
+            <a:off x="5029200" y="3017520"/>
+            <a:ext cx="2926080" cy="1828800"/>
+          </a:xfrm>
+          <a:prstGeom prst="rect">
+            <a:avLst/>
+          </a:prstGeom>
+        </p:spPr>
+      </p:pic>
     </p:spTree>
   </p:cSld>
 </p:sld>

</xml_diff>

<commit_message>
PPTX shape geometry: presets + custGeom + outline
dv-pptx: parse a:prstGeom (prst + a:gd adjusts), a:custGeom (a:path moveTo/lnTo/
cubicBezTo/close with a:pt buffering), and a:ln outline (in_ln disambiguates
srgbClr -> outline vs fill). 12 preset path generators (rect/roundRect/ellipse/
triangle/rtTriangle/diamond/parallelogram/trapezoid/pentagon/hexagon/right+left
arrow) in local px; line/connector -> stroke only; unknown -> rect. Render fills +
outlines via FillPath/StrokePath with a per-shape scale+translate transform.

Verified in-browser: a slide of roundRect/ellipse/rightArrow/triangle/pentagon +
a custGeom polygon, each with fill, outline, and centred text.

Co-Authored-By: Claude Opus 4.8 (1M context) <noreply@anthropic.com>
</commit_message>
<xml_diff>
--- a/examples/assets/sample.pptx
+++ b/examples/assets/sample.pptx
@@ -4,6 +4,7 @@
   <p:sldIdLst>
     <p:sldId id="256" r:id="rId1"/>
     <p:sldId id="257" r:id="rId2"/>
+    <p:sldId id="258" r:id="rId3"/>
   </p:sldIdLst>
   <p:sldSz cx="9144000" cy="6858000"/>
 </p:presentation>
@@ -311,4 +312,266 @@
     </p:spTree>
   </p:cSld>
 </p:sld>
+</file>
+
+<file path=ppt/slides/slide3.xml><?xml version="1.0" encoding="utf-8"?>
+<p:sld xmlns:a="http://schemas.openxmlformats.org/drawingml/2006/main" xmlns:r="http://schemas.openxmlformats.org/officeDocument/2006/relationships" xmlns:p="http://schemas.openxmlformats.org/presentationml/2006/main">
+  <p:cSld>
+    <p:spTree>
+      <p:nvGrpSpPr>
+        <p:cNvPr id="1" name=""/>
+        <p:cNvGrpSpPr/>
+        <p:nvPr/>
+      </p:nvGrpSpPr>
+      <p:grpSpPr/>
+      <p:sp>
+        <p:nvSpPr>
+          <p:cNvPr id="2" name="tb2"/>
+          <p:cNvSpPr/>
+          <p:nvPr/>
+        </p:nvSpPr>
+        <p:spPr>
+          <a:xfrm>
+            <a:off x="457200" y="182880"/>
+            <a:ext cx="8229600" cy="731520"/>
+          </a:xfrm>
+          <a:prstGeom prst="rect">
+            <a:avLst/>
+          </a:prstGeom>
+          <a:noFill/>
+        </p:spPr>
+        <p:txBody>
+          <a:bodyPr/>
+          <a:lstStyle/>
+          <a:p>
+            <a:pPr algn="left"/>
+            <a:r>
+              <a:rPr lang="zh-Hant" sz="2400" b="1">
+                <a:solidFill>
+                  <a:srgbClr val="1F2937"/>
+                </a:solidFill>
+              </a:rPr>
+              <a:t>第三張投影片 — 形狀幾何 (preset + custGeom + 外框)</a:t>
+            </a:r>
+          </a:p>
+        </p:txBody>
+      </p:sp>
+      <p:sp>
+        <p:nvSpPr>
+          <p:cNvPr id="3" name="sp3"/>
+          <p:cNvSpPr/>
+          <p:nvPr/>
+        </p:nvSpPr>
+        <p:spPr>
+          <a:xfrm>
+            <a:off x="457200" y="1097280"/>
+            <a:ext cx="2560320" cy="1280160"/>
+          </a:xfrm>
+          <a:prstGeom prst="roundRect">
+            <a:avLst/>
+          </a:prstGeom>
+          <a:solidFill>
+            <a:srgbClr val="4F81BD"/>
+          </a:solidFill>
+          <a:ln w="25400">
+            <a:solidFill>
+              <a:srgbClr val="1F3864"/>
+            </a:solidFill>
+          </a:ln>
+        </p:spPr>
+        <p:txBody>
+          <a:bodyPr/>
+          <a:lstStyle/>
+          <a:p>
+            <a:pPr algn="ctr"/>
+            <a:r>
+              <a:rPr sz="1800" b="1">
+                <a:solidFill>
+                  <a:srgbClr val="FFFFFF"/>
+                </a:solidFill>
+              </a:rPr>
+              <a:t>圓角矩形</a:t>
+            </a:r>
+          </a:p>
+        </p:txBody>
+      </p:sp>
+      <p:sp>
+        <p:nvSpPr>
+          <p:cNvPr id="4" name="sp4"/>
+          <p:cNvSpPr/>
+          <p:nvPr/>
+        </p:nvSpPr>
+        <p:spPr>
+          <a:xfrm>
+            <a:off x="3291840" y="1097280"/>
+            <a:ext cx="2377440" cy="1280160"/>
+          </a:xfrm>
+          <a:prstGeom prst="ellipse">
+            <a:avLst/>
+          </a:prstGeom>
+          <a:solidFill>
+            <a:srgbClr val="C0504D"/>
+          </a:solidFill>
+          <a:ln w="25400">
+            <a:solidFill>
+              <a:srgbClr val="7F1D1D"/>
+            </a:solidFill>
+          </a:ln>
+        </p:spPr>
+        <p:txBody>
+          <a:bodyPr/>
+          <a:lstStyle/>
+          <a:p>
+            <a:pPr algn="ctr"/>
+            <a:r>
+              <a:rPr sz="1800" b="1">
+                <a:solidFill>
+                  <a:srgbClr val="FFFFFF"/>
+                </a:solidFill>
+              </a:rPr>
+              <a:t>橢圓</a:t>
+            </a:r>
+          </a:p>
+        </p:txBody>
+      </p:sp>
+      <p:sp>
+        <p:nvSpPr>
+          <p:cNvPr id="5" name="sp5"/>
+          <p:cNvSpPr/>
+          <p:nvPr/>
+        </p:nvSpPr>
+        <p:spPr>
+          <a:xfrm>
+            <a:off x="5943600" y="1234440"/>
+            <a:ext cx="2743200" cy="1005840"/>
+          </a:xfrm>
+          <a:prstGeom prst="rightArrow">
+            <a:avLst/>
+          </a:prstGeom>
+          <a:solidFill>
+            <a:srgbClr val="9BBB59"/>
+          </a:solidFill>
+          <a:ln w="25400">
+            <a:solidFill>
+              <a:srgbClr val="4F6228"/>
+            </a:solidFill>
+          </a:ln>
+        </p:spPr>
+        <p:txBody>
+          <a:bodyPr/>
+          <a:lstStyle/>
+          <a:p/>
+        </p:txBody>
+      </p:sp>
+      <p:sp>
+        <p:nvSpPr>
+          <p:cNvPr id="6" name="sp6"/>
+          <p:cNvSpPr/>
+          <p:nvPr/>
+        </p:nvSpPr>
+        <p:spPr>
+          <a:xfrm>
+            <a:off x="457200" y="2743200"/>
+            <a:ext cx="2194560" cy="2011680"/>
+          </a:xfrm>
+          <a:prstGeom prst="triangle">
+            <a:avLst/>
+          </a:prstGeom>
+          <a:solidFill>
+            <a:srgbClr val="F79646"/>
+          </a:solidFill>
+          <a:ln w="25400">
+            <a:solidFill>
+              <a:srgbClr val="974806"/>
+            </a:solidFill>
+          </a:ln>
+        </p:spPr>
+        <p:txBody>
+          <a:bodyPr/>
+          <a:lstStyle/>
+          <a:p/>
+        </p:txBody>
+      </p:sp>
+      <p:sp>
+        <p:nvSpPr>
+          <p:cNvPr id="7" name="sp7"/>
+          <p:cNvSpPr/>
+          <p:nvPr/>
+        </p:nvSpPr>
+        <p:spPr>
+          <a:xfrm>
+            <a:off x="3017520" y="2743200"/>
+            <a:ext cx="2194560" cy="2011680"/>
+          </a:xfrm>
+          <a:prstGeom prst="pentagon">
+            <a:avLst/>
+          </a:prstGeom>
+          <a:solidFill>
+            <a:srgbClr val="4BACC6"/>
+          </a:solidFill>
+          <a:ln w="25400">
+            <a:solidFill>
+              <a:srgbClr val="215868"/>
+            </a:solidFill>
+          </a:ln>
+        </p:spPr>
+        <p:txBody>
+          <a:bodyPr/>
+          <a:lstStyle/>
+          <a:p/>
+        </p:txBody>
+      </p:sp>
+      <p:sp>
+        <p:nvSpPr>
+          <p:cNvPr id="8" name="cg8"/>
+          <p:cNvSpPr/>
+          <p:nvPr/>
+        </p:nvSpPr>
+        <p:spPr>
+          <a:xfrm>
+            <a:off x="5669280" y="2743200"/>
+            <a:ext cx="2377440" cy="2011680"/>
+          </a:xfrm>
+          <a:custGeom>
+            <a:avLst/>
+            <a:gdLst/>
+            <a:pathLst>
+              <a:path w="100000" h="100000">
+                <a:moveTo>
+                  <a:pt x="50000" y="0"/>
+                </a:moveTo>
+                <a:lnTo>
+                  <a:pt x="100000" y="38000"/>
+                </a:lnTo>
+                <a:lnTo>
+                  <a:pt x="82000" y="100000"/>
+                </a:lnTo>
+                <a:lnTo>
+                  <a:pt x="18000" y="100000"/>
+                </a:lnTo>
+                <a:lnTo>
+                  <a:pt x="0" y="38000"/>
+                </a:lnTo>
+                <a:close/>
+              </a:path>
+            </a:pathLst>
+          </a:custGeom>
+          <a:solidFill>
+            <a:srgbClr val="8064A2"/>
+          </a:solidFill>
+          <a:ln w="25400">
+            <a:solidFill>
+              <a:srgbClr val="3F3151"/>
+            </a:solidFill>
+          </a:ln>
+        </p:spPr>
+        <p:txBody>
+          <a:bodyPr/>
+          <a:lstStyle/>
+          <a:p/>
+        </p:txBody>
+      </p:sp>
+    </p:spTree>
+  </p:cSld>
+</p:sld>
 </file>
</xml_diff>